<commit_message>
fix: mark T-Bank credit API unavailable
</commit_message>
<xml_diff>
--- a/russian-banks-api-research.pptx
+++ b/russian-banks-api-research.pptx
@@ -16253,7 +16253,371 @@
 </p:sld>
 </file>
 
-<file path=ppt/slides/slide29.xml><?xml version="1.0" encoding="utf-8"?>
+<file path=ppt/slides/slide1.xml><?xml version="1.0" encoding="utf-8"?>
+<p:sld xmlns:a="http://schemas.openxmlformats.org/drawingml/2006/main" xmlns:r="http://schemas.openxmlformats.org/officeDocument/2006/relationships" xmlns:p="http://schemas.openxmlformats.org/presentationml/2006/main">
+  <p:cSld>
+    <p:spTree>
+      <p:nvGrpSpPr>
+        <p:cNvPr id="1" name=""/>
+        <p:cNvGrpSpPr/>
+        <p:nvPr/>
+      </p:nvGrpSpPr>
+      <p:grpSpPr>
+        <a:xfrm>
+          <a:off x="0" y="0"/>
+          <a:ext cx="0" cy="0"/>
+          <a:chOff x="0" y="0"/>
+          <a:chExt cx="0" cy="0"/>
+        </a:xfrm>
+      </p:grpSpPr>
+      <p:pic>
+        <p:nvPicPr>
+          <p:cNvPr id="3" name="Рисунок 2">
+            <a:extLst>
+              <a:ext uri="{FF2B5EF4-FFF2-40B4-BE49-F238E27FC236}">
+                <a16:creationId xmlns:a16="http://schemas.microsoft.com/office/drawing/2014/main" id="{B3FD0DC7-A0AA-8E46-A52B-B44F27D857EB}"/>
+              </a:ext>
+            </a:extLst>
+          </p:cNvPr>
+          <p:cNvPicPr>
+            <a:picLocks noChangeAspect="1"/>
+          </p:cNvPicPr>
+          <p:nvPr/>
+        </p:nvPicPr>
+        <p:blipFill rotWithShape="1">
+          <a:blip r:embed="rId3" cstate="email">
+            <a:alphaModFix/>
+            <a:extLst>
+              <a:ext uri="{28A0092B-C50C-407E-A947-70E740481C1C}">
+                <a14:useLocalDpi xmlns:a14="http://schemas.microsoft.com/office/drawing/2010/main"/>
+              </a:ext>
+            </a:extLst>
+          </a:blip>
+          <a:srcRect/>
+          <a:stretch/>
+        </p:blipFill>
+        <p:spPr>
+          <a:xfrm>
+            <a:off x="3218219" y="0"/>
+            <a:ext cx="8973782" cy="6879759"/>
+          </a:xfrm>
+          <a:prstGeom prst="rect">
+            <a:avLst/>
+          </a:prstGeom>
+        </p:spPr>
+      </p:pic>
+      <p:sp>
+        <p:nvSpPr>
+          <p:cNvPr id="8" name="Прямоугольник">
+            <a:extLst>
+              <a:ext uri="{FF2B5EF4-FFF2-40B4-BE49-F238E27FC236}">
+                <a16:creationId xmlns:a16="http://schemas.microsoft.com/office/drawing/2014/main" id="{38AF4049-ECF2-3C44-9AF4-FCFEAD35A479}"/>
+              </a:ext>
+            </a:extLst>
+          </p:cNvPr>
+          <p:cNvSpPr/>
+          <p:nvPr/>
+        </p:nvSpPr>
+        <p:spPr>
+          <a:xfrm>
+            <a:off x="-1086567" y="-3420818"/>
+            <a:ext cx="9469284" cy="15808703"/>
+          </a:xfrm>
+          <a:prstGeom prst="rect">
+            <a:avLst/>
+          </a:prstGeom>
+          <a:gradFill>
+            <a:gsLst>
+              <a:gs pos="50843">
+                <a:srgbClr val="FFFFFF"/>
+              </a:gs>
+              <a:gs pos="78055">
+                <a:srgbClr val="FFFFFF">
+                  <a:alpha val="50000"/>
+                </a:srgbClr>
+              </a:gs>
+              <a:gs pos="100000">
+                <a:srgbClr val="FFFFFF">
+                  <a:alpha val="0"/>
+                </a:srgbClr>
+              </a:gs>
+            </a:gsLst>
+            <a:path>
+              <a:fillToRect l="-4239" t="49577" r="104239" b="50422"/>
+            </a:path>
+          </a:gradFill>
+          <a:ln w="12700">
+            <a:miter lim="400000"/>
+          </a:ln>
+        </p:spPr>
+        <p:txBody>
+          <a:bodyPr lIns="45718" tIns="45718" rIns="45718" bIns="45718" anchor="ctr"/>
+          <a:lstStyle/>
+          <a:p>
+            <a:endParaRPr/>
+          </a:p>
+        </p:txBody>
+      </p:sp>
+      <p:sp>
+        <p:nvSpPr>
+          <p:cNvPr id="376" name="Text Placeholder 3"/>
+          <p:cNvSpPr txBox="1"/>
+          <p:nvPr/>
+        </p:nvSpPr>
+        <p:spPr>
+          <a:xfrm>
+            <a:off x="1708231" y="4782396"/>
+            <a:ext cx="2106506" cy="228601"/>
+          </a:xfrm>
+          <a:prstGeom prst="rect">
+            <a:avLst/>
+          </a:prstGeom>
+          <a:ln w="12700">
+            <a:miter lim="400000"/>
+          </a:ln>
+          <a:extLst>
+            <a:ext uri="{C572A759-6A51-4108-AA02-DFA0A04FC94B}">
+              <ma14:wrappingTextBoxFlag xmlns="" xmlns:m="http://schemas.openxmlformats.org/officeDocument/2006/math" xmlns:a14="http://schemas.microsoft.com/office/drawing/2010/main" xmlns:ma14="http://schemas.microsoft.com/office/mac/drawingml/2011/main" val="1"/>
+            </a:ext>
+          </a:extLst>
+        </p:spPr>
+        <p:txBody>
+          <a:bodyPr lIns="0" tIns="0" rIns="0" bIns="0">
+            <a:spAutoFit/>
+          </a:bodyPr>
+          <a:lstStyle>
+            <a:lvl1pPr defTabSz="359999">
+              <a:defRPr sz="1400">
+                <a:solidFill>
+                  <a:srgbClr val="FFFFFF"/>
+                </a:solidFill>
+                <a:latin typeface="SB Sans Text Light"/>
+                <a:ea typeface="SB Sans Text Light"/>
+                <a:cs typeface="SB Sans Text Light"/>
+                <a:sym typeface="SB Sans Text Light"/>
+              </a:defRPr>
+            </a:lvl1pPr>
+          </a:lstStyle>
+          <a:p>
+            <a:r>
+              <a:t>2/06/2021</a:t>
+            </a:r>
+          </a:p>
+        </p:txBody>
+      </p:sp>
+      <p:pic>
+        <p:nvPicPr>
+          <p:cNvPr id="378" name="Object 3" descr="Object 3"/>
+          <p:cNvPicPr>
+            <a:picLocks noChangeAspect="1"/>
+          </p:cNvPicPr>
+          <p:nvPr/>
+        </p:nvPicPr>
+        <p:blipFill>
+          <a:blip r:embed="rId4" cstate="email">
+            <a:extLst>
+              <a:ext uri="{28A0092B-C50C-407E-A947-70E740481C1C}">
+                <a14:useLocalDpi xmlns:a14="http://schemas.microsoft.com/office/drawing/2010/main"/>
+              </a:ext>
+            </a:extLst>
+          </a:blip>
+          <a:stretch>
+            <a:fillRect/>
+          </a:stretch>
+        </p:blipFill>
+        <p:spPr>
+          <a:xfrm>
+            <a:off x="1163637" y="668326"/>
+            <a:ext cx="1495481" cy="307484"/>
+          </a:xfrm>
+          <a:prstGeom prst="rect">
+            <a:avLst/>
+          </a:prstGeom>
+          <a:ln w="12700">
+            <a:miter lim="400000"/>
+          </a:ln>
+        </p:spPr>
+      </p:pic>
+      <p:sp>
+        <p:nvSpPr>
+          <p:cNvPr id="379" name="Text Placeholder 3"/>
+          <p:cNvSpPr txBox="1"/>
+          <p:nvPr/>
+        </p:nvSpPr>
+        <p:spPr>
+          <a:xfrm>
+            <a:off x="1163637" y="5798021"/>
+            <a:ext cx="4968876" cy="215444"/>
+          </a:xfrm>
+          <a:prstGeom prst="rect">
+            <a:avLst/>
+          </a:prstGeom>
+          <a:ln w="12700">
+            <a:miter lim="400000"/>
+          </a:ln>
+          <a:extLst>
+            <a:ext uri="{C572A759-6A51-4108-AA02-DFA0A04FC94B}">
+              <ma14:wrappingTextBoxFlag xmlns="" xmlns:m="http://schemas.openxmlformats.org/officeDocument/2006/math" xmlns:a14="http://schemas.microsoft.com/office/drawing/2010/main" xmlns:ma14="http://schemas.microsoft.com/office/mac/drawingml/2011/main" val="1"/>
+            </a:ext>
+          </a:extLst>
+        </p:spPr>
+        <p:txBody>
+          <a:bodyPr wrap="square" lIns="0" tIns="0" rIns="0" bIns="0" anchor="b">
+            <a:spAutoFit/>
+          </a:bodyPr>
+          <a:lstStyle>
+            <a:lvl1pPr defTabSz="359999">
+              <a:defRPr sz="1400">
+                <a:solidFill>
+                  <a:srgbClr val="3F4851"/>
+                </a:solidFill>
+                <a:latin typeface="SB Sans Text Light"/>
+                <a:ea typeface="SB Sans Text Light"/>
+                <a:cs typeface="SB Sans Text Light"/>
+                <a:sym typeface="SB Sans Text Light"/>
+              </a:defRPr>
+            </a:lvl1pPr>
+          </a:lstStyle>
+          <a:p>
+            <a:r>
+              <a:rPr lang="ru-RU" dirty="0"/>
+              <a:t>Февраль 2021</a:t>
+            </a:r>
+          </a:p>
+        </p:txBody>
+      </p:sp>
+      <p:sp>
+        <p:nvSpPr>
+          <p:cNvPr id="11" name="TextBox 10">
+            <a:extLst>
+              <a:ext uri="{FF2B5EF4-FFF2-40B4-BE49-F238E27FC236}">
+                <a16:creationId xmlns:a16="http://schemas.microsoft.com/office/drawing/2014/main" id="{6E781A54-7BEA-464D-BE1E-B3D62E989D7D}"/>
+              </a:ext>
+            </a:extLst>
+          </p:cNvPr>
+          <p:cNvSpPr txBox="1"/>
+          <p:nvPr/>
+        </p:nvSpPr>
+        <p:spPr>
+          <a:xfrm>
+            <a:off x="1163637" y="2751319"/>
+            <a:ext cx="5177421" cy="1338824"/>
+          </a:xfrm>
+          <a:prstGeom prst="rect">
+            <a:avLst/>
+          </a:prstGeom>
+          <a:noFill/>
+          <a:ln w="12700" cap="flat">
+            <a:noFill/>
+            <a:miter lim="400000"/>
+          </a:ln>
+          <a:effectLst/>
+          <a:sp3d/>
+        </p:spPr>
+        <p:style>
+          <a:lnRef idx="0">
+            <a:scrgbClr r="0" g="0" b="0"/>
+          </a:lnRef>
+          <a:fillRef idx="0">
+            <a:scrgbClr r="0" g="0" b="0"/>
+          </a:fillRef>
+          <a:effectRef idx="0">
+            <a:scrgbClr r="0" g="0" b="0"/>
+          </a:effectRef>
+          <a:fontRef idx="none"/>
+        </p:style>
+        <p:txBody>
+          <a:bodyPr rot="0" spcFirstLastPara="1" vertOverflow="overflow" horzOverflow="overflow" vert="horz" wrap="square" lIns="45718" tIns="45718" rIns="45718" bIns="45718" numCol="1" spcCol="38100" rtlCol="0" anchor="t">
+            <a:spAutoFit/>
+          </a:bodyPr>
+          <a:lstStyle/>
+          <a:p>
+            <a:pPr marL="0" marR="0" indent="0" algn="l" defTabSz="914400" rtl="0" fontAlgn="auto" latinLnBrk="0" hangingPunct="0">
+              <a:lnSpc>
+                <a:spcPct val="90000"/>
+              </a:lnSpc>
+              <a:spcBef>
+                <a:spcPts val="0"/>
+              </a:spcBef>
+              <a:spcAft>
+                <a:spcPts val="0"/>
+              </a:spcAft>
+              <a:buClrTx/>
+              <a:buSzTx/>
+              <a:buFontTx/>
+              <a:buNone/>
+              <a:tabLst/>
+            </a:pPr>
+            <a:r>
+              <a:rPr lang="ru-RU" sz="3000" dirty="0">
+                <a:latin typeface="SB Sans Display Semibold" panose="020B0503040504020204" pitchFamily="34" charset="0"/>
+                <a:cs typeface="SB Sans Display Semibold" panose="020B0503040504020204" pitchFamily="34" charset="0"/>
+              </a:rPr>
+              <a:t>Заголовок.</a:t>
+            </a:r>
+          </a:p>
+          <a:p>
+            <a:pPr marL="0" marR="0" indent="0" algn="l" defTabSz="914400" rtl="0" fontAlgn="auto" latinLnBrk="0" hangingPunct="0">
+              <a:lnSpc>
+                <a:spcPct val="90000"/>
+              </a:lnSpc>
+              <a:spcBef>
+                <a:spcPts val="0"/>
+              </a:spcBef>
+              <a:spcAft>
+                <a:spcPts val="0"/>
+              </a:spcAft>
+              <a:buClrTx/>
+              <a:buSzTx/>
+              <a:buFontTx/>
+              <a:buNone/>
+              <a:tabLst/>
+            </a:pPr>
+            <a:r>
+              <a:rPr lang="ru-RU" sz="3000" dirty="0">
+                <a:latin typeface="SB Sans Display" panose="020B0503040504020204" pitchFamily="34" charset="0"/>
+                <a:cs typeface="SB Sans Display" panose="020B0503040504020204" pitchFamily="34" charset="0"/>
+              </a:rPr>
+              <a:t>С выделением первого</a:t>
+            </a:r>
+          </a:p>
+          <a:p>
+            <a:pPr marL="0" marR="0" indent="0" algn="l" defTabSz="914400" rtl="0" fontAlgn="auto" latinLnBrk="0" hangingPunct="0">
+              <a:lnSpc>
+                <a:spcPct val="90000"/>
+              </a:lnSpc>
+              <a:spcBef>
+                <a:spcPts val="0"/>
+              </a:spcBef>
+              <a:spcAft>
+                <a:spcPts val="0"/>
+              </a:spcAft>
+              <a:buClrTx/>
+              <a:buSzTx/>
+              <a:buFontTx/>
+              <a:buNone/>
+              <a:tabLst/>
+            </a:pPr>
+            <a:r>
+              <a:rPr lang="ru-RU" sz="3000" dirty="0">
+                <a:latin typeface="SB Sans Display" panose="020B0503040504020204" pitchFamily="34" charset="0"/>
+                <a:cs typeface="SB Sans Display" panose="020B0503040504020204" pitchFamily="34" charset="0"/>
+              </a:rPr>
+              <a:t>слова на верхней строчке</a:t>
+            </a:r>
+          </a:p>
+        </p:txBody>
+      </p:sp>
+    </p:spTree>
+  </p:cSld>
+  <p:clrMapOvr>
+    <a:masterClrMapping/>
+  </p:clrMapOvr>
+  <p:transition spd="med"/>
+</p:sld>
+</file>
+
+<file path=ppt/slides/slide10.xml><?xml version="1.0" encoding="utf-8"?>
 <p:sld xmlns:a="http://schemas.openxmlformats.org/drawingml/2006/main" xmlns:p="http://schemas.openxmlformats.org/presentationml/2006/main" xmlns:r="http://schemas.openxmlformats.org/officeDocument/2006/relationships">
   <p:cSld>
     <p:spTree>
@@ -16546,7 +16910,7 @@
                 <a:latin typeface="SB Sans Display Semibold" panose="020B0503040504020204" pitchFamily="34" charset="0"/>
                 <a:cs typeface="SB Sans Display Semibold" panose="020B0503040504020204" pitchFamily="34" charset="0"/>
               </a:rPr>
-              <a:t>Топ банков РФ</a:t>
+              <a:t>Спасибо</a:t>
             </a:r>
           </a:p>
           <a:p>
@@ -16571,7 +16935,7 @@
                 <a:latin typeface="SB Sans Display" panose="020B0503040504020204" pitchFamily="34" charset="0"/>
                 <a:cs typeface="SB Sans Display" panose="020B0503040504020204" pitchFamily="34" charset="0"/>
               </a:rPr>
-              <a:t>и их API:</a:t>
+              <a:t>Отчёт и преза —</a:t>
             </a:r>
           </a:p>
           <a:p>
@@ -16596,7 +16960,7 @@
                 <a:latin typeface="SB Sans Display" panose="020B0503040504020204" pitchFamily="34" charset="0"/>
                 <a:cs typeface="SB Sans Display" panose="020B0503040504020204" pitchFamily="34" charset="0"/>
               </a:rPr>
-              <a:t>публичный ресерч</a:t>
+              <a:t>в репозитории</a:t>
             </a:r>
           </a:p>
         </p:txBody>
@@ -16609,7 +16973,7 @@
 </p:sld>
 </file>
 
-<file path=ppt/slides/slide30.xml><?xml version="1.0" encoding="utf-8"?>
+<file path=ppt/slides/slide2.xml><?xml version="1.0" encoding="utf-8"?>
 <p:sld xmlns:a="http://schemas.openxmlformats.org/drawingml/2006/main" xmlns:p="http://schemas.openxmlformats.org/presentationml/2006/main" xmlns:r="http://schemas.openxmlformats.org/officeDocument/2006/relationships">
   <p:cSld>
     <p:spTree>
@@ -16968,7 +17332,7 @@
 </p:sld>
 </file>
 
-<file path=ppt/slides/slide31.xml><?xml version="1.0" encoding="utf-8"?>
+<file path=ppt/slides/slide3.xml><?xml version="1.0" encoding="utf-8"?>
 <p:sld xmlns:a="http://schemas.openxmlformats.org/drawingml/2006/main" xmlns:p="http://schemas.openxmlformats.org/presentationml/2006/main" xmlns:r="http://schemas.openxmlformats.org/officeDocument/2006/relationships">
   <p:cSld>
     <p:spTree>
@@ -19272,7 +19636,7 @@
 </p:sld>
 </file>
 
-<file path=ppt/slides/slide32.xml><?xml version="1.0" encoding="utf-8"?>
+<file path=ppt/slides/slide4.xml><?xml version="1.0" encoding="utf-8"?>
 <p:sld xmlns:a="http://schemas.openxmlformats.org/drawingml/2006/main" xmlns:p="http://schemas.openxmlformats.org/presentationml/2006/main" xmlns:r="http://schemas.openxmlformats.org/officeDocument/2006/relationships">
   <p:cSld>
     <p:spTree>
@@ -20066,7 +20430,7 @@
 </p:sld>
 </file>
 
-<file path=ppt/slides/slide33.xml><?xml version="1.0" encoding="utf-8"?>
+<file path=ppt/slides/slide5.xml><?xml version="1.0" encoding="utf-8"?>
 <p:sld xmlns:a="http://schemas.openxmlformats.org/drawingml/2006/main" xmlns:p="http://schemas.openxmlformats.org/presentationml/2006/main" xmlns:r="http://schemas.openxmlformats.org/officeDocument/2006/relationships">
   <p:cSld>
     <p:spTree>
@@ -22243,7 +22607,7 @@
 </p:sld>
 </file>
 
-<file path=ppt/slides/slide34.xml><?xml version="1.0" encoding="utf-8"?>
+<file path=ppt/slides/slide6.xml><?xml version="1.0" encoding="utf-8"?>
 <p:sld xmlns:a="http://schemas.openxmlformats.org/drawingml/2006/main" xmlns:p="http://schemas.openxmlformats.org/presentationml/2006/main" xmlns:r="http://schemas.openxmlformats.org/officeDocument/2006/relationships">
   <p:cSld>
     <p:spTree>
@@ -24951,7 +25315,7 @@
                     <a:lstStyle/>
                     <a:p>
                       <a:r>
-                        <a:t>◐</a:t>
+                        <a:t>❌</a:t>
                       </a:r>
                     </a:p>
                   </a:txBody>
@@ -26930,7 +27294,7 @@
 </p:sld>
 </file>
 
-<file path=ppt/slides/slide35.xml><?xml version="1.0" encoding="utf-8"?>
+<file path=ppt/slides/slide7.xml><?xml version="1.0" encoding="utf-8"?>
 <p:sld xmlns:a="http://schemas.openxmlformats.org/drawingml/2006/main" xmlns:p="http://schemas.openxmlformats.org/presentationml/2006/main" xmlns:r="http://schemas.openxmlformats.org/officeDocument/2006/relationships">
   <p:cSld>
     <p:spTree>
@@ -27724,7 +28088,7 @@
 </p:sld>
 </file>
 
-<file path=ppt/slides/slide36.xml><?xml version="1.0" encoding="utf-8"?>
+<file path=ppt/slides/slide8.xml><?xml version="1.0" encoding="utf-8"?>
 <p:sld xmlns:a="http://schemas.openxmlformats.org/drawingml/2006/main" xmlns:p="http://schemas.openxmlformats.org/presentationml/2006/main" xmlns:r="http://schemas.openxmlformats.org/officeDocument/2006/relationships">
   <p:cSld>
     <p:spTree>
@@ -29901,7 +30265,7 @@
 </p:sld>
 </file>
 
-<file path=ppt/slides/slide37.xml><?xml version="1.0" encoding="utf-8"?>
+<file path=ppt/slides/slide9.xml><?xml version="1.0" encoding="utf-8"?>
 <p:sld xmlns:a="http://schemas.openxmlformats.org/drawingml/2006/main" xmlns:p="http://schemas.openxmlformats.org/presentationml/2006/main" xmlns:r="http://schemas.openxmlformats.org/officeDocument/2006/relationships">
   <p:cSld>
     <p:spTree>
@@ -30249,362 +30613,6 @@
               <a:cs typeface="SB Sans Text Light" panose="020B0303040504020204" pitchFamily="34" charset="0"/>
               <a:sym typeface="Helvetica"/>
             </a:endParaRPr>
-          </a:p>
-        </p:txBody>
-      </p:sp>
-    </p:spTree>
-  </p:cSld>
-  <p:clrMapOvr>
-    <a:masterClrMapping/>
-  </p:clrMapOvr>
-</p:sld>
-</file>
-
-<file path=ppt/slides/slide38.xml><?xml version="1.0" encoding="utf-8"?>
-<p:sld xmlns:a="http://schemas.openxmlformats.org/drawingml/2006/main" xmlns:p="http://schemas.openxmlformats.org/presentationml/2006/main" xmlns:r="http://schemas.openxmlformats.org/officeDocument/2006/relationships">
-  <p:cSld>
-    <p:spTree>
-      <p:nvGrpSpPr>
-        <p:cNvPr id="1" name=""/>
-        <p:cNvGrpSpPr/>
-        <p:nvPr/>
-      </p:nvGrpSpPr>
-      <p:grpSpPr/>
-      <p:pic>
-        <p:nvPicPr>
-          <p:cNvPr id="3" name="Рисунок 2">
-            <a:extLst>
-              <a:ext uri="{FF2B5EF4-FFF2-40B4-BE49-F238E27FC236}">
-                <a16:creationId xmlns:a16="http://schemas.microsoft.com/office/drawing/2014/main" id="{B3FD0DC7-A0AA-8E46-A52B-B44F27D857EB}"/>
-              </a:ext>
-            </a:extLst>
-          </p:cNvPr>
-          <p:cNvPicPr>
-            <a:picLocks noChangeAspect="1"/>
-          </p:cNvPicPr>
-          <p:nvPr/>
-        </p:nvPicPr>
-        <p:blipFill rotWithShape="1">
-          <a:blip r:embed="rId2" cstate="email">
-            <a:alphaModFix/>
-            <a:extLst>
-              <a:ext uri="{28A0092B-C50C-407E-A947-70E740481C1C}">
-                <a14:useLocalDpi xmlns:a14="http://schemas.microsoft.com/office/drawing/2010/main"/>
-              </a:ext>
-            </a:extLst>
-          </a:blip>
-          <a:srcRect/>
-          <a:stretch/>
-        </p:blipFill>
-        <p:spPr>
-          <a:xfrm>
-            <a:off x="3218219" y="0"/>
-            <a:ext cx="8973782" cy="6879759"/>
-          </a:xfrm>
-          <a:prstGeom prst="rect">
-            <a:avLst/>
-          </a:prstGeom>
-        </p:spPr>
-      </p:pic>
-      <p:sp>
-        <p:nvSpPr>
-          <p:cNvPr id="8" name="Прямоугольник">
-            <a:extLst>
-              <a:ext uri="{FF2B5EF4-FFF2-40B4-BE49-F238E27FC236}">
-                <a16:creationId xmlns:a16="http://schemas.microsoft.com/office/drawing/2014/main" id="{38AF4049-ECF2-3C44-9AF4-FCFEAD35A479}"/>
-              </a:ext>
-            </a:extLst>
-          </p:cNvPr>
-          <p:cNvSpPr/>
-          <p:nvPr/>
-        </p:nvSpPr>
-        <p:spPr>
-          <a:xfrm>
-            <a:off x="-1086567" y="-3420818"/>
-            <a:ext cx="9469284" cy="15808703"/>
-          </a:xfrm>
-          <a:prstGeom prst="rect">
-            <a:avLst/>
-          </a:prstGeom>
-          <a:gradFill>
-            <a:gsLst>
-              <a:gs pos="50843">
-                <a:srgbClr val="FFFFFF"/>
-              </a:gs>
-              <a:gs pos="78055">
-                <a:srgbClr val="FFFFFF">
-                  <a:alpha val="50000"/>
-                </a:srgbClr>
-              </a:gs>
-              <a:gs pos="100000">
-                <a:srgbClr val="FFFFFF">
-                  <a:alpha val="0"/>
-                </a:srgbClr>
-              </a:gs>
-            </a:gsLst>
-            <a:path>
-              <a:fillToRect l="-4239" t="49577" r="104239" b="50422"/>
-            </a:path>
-          </a:gradFill>
-          <a:ln w="12700">
-            <a:miter lim="400000"/>
-          </a:ln>
-        </p:spPr>
-        <p:txBody>
-          <a:bodyPr lIns="45718" tIns="45718" rIns="45718" bIns="45718" anchor="ctr"/>
-          <a:lstStyle/>
-          <a:p>
-            <a:endParaRPr/>
-          </a:p>
-        </p:txBody>
-      </p:sp>
-      <p:sp>
-        <p:nvSpPr>
-          <p:cNvPr id="376" name="Text Placeholder 3"/>
-          <p:cNvSpPr txBox="1"/>
-          <p:nvPr/>
-        </p:nvSpPr>
-        <p:spPr>
-          <a:xfrm>
-            <a:off x="1708231" y="4782396"/>
-            <a:ext cx="2106506" cy="228601"/>
-          </a:xfrm>
-          <a:prstGeom prst="rect">
-            <a:avLst/>
-          </a:prstGeom>
-          <a:ln w="12700">
-            <a:miter lim="400000"/>
-          </a:ln>
-          <a:extLst>
-            <a:ext uri="{C572A759-6A51-4108-AA02-DFA0A04FC94B}">
-              <ma14:wrappingTextBoxFlag xmlns="" xmlns:m="http://schemas.openxmlformats.org/officeDocument/2006/math" xmlns:a14="http://schemas.microsoft.com/office/drawing/2010/main" xmlns:ma14="http://schemas.microsoft.com/office/mac/drawingml/2011/main" val="1"/>
-            </a:ext>
-          </a:extLst>
-        </p:spPr>
-        <p:txBody>
-          <a:bodyPr lIns="0" tIns="0" rIns="0" bIns="0">
-            <a:spAutoFit/>
-          </a:bodyPr>
-          <a:lstStyle>
-            <a:lvl1pPr defTabSz="359999">
-              <a:defRPr sz="1400">
-                <a:solidFill>
-                  <a:srgbClr val="FFFFFF"/>
-                </a:solidFill>
-                <a:latin typeface="SB Sans Text Light"/>
-                <a:ea typeface="SB Sans Text Light"/>
-                <a:cs typeface="SB Sans Text Light"/>
-                <a:sym typeface="SB Sans Text Light"/>
-              </a:defRPr>
-            </a:lvl1pPr>
-          </a:lstStyle>
-          <a:p>
-            <a:r>
-              <a:t>08/10/2026</a:t>
-            </a:r>
-          </a:p>
-        </p:txBody>
-      </p:sp>
-      <p:pic>
-        <p:nvPicPr>
-          <p:cNvPr id="378" name="Object 3" descr="Object 3"/>
-          <p:cNvPicPr>
-            <a:picLocks noChangeAspect="1"/>
-          </p:cNvPicPr>
-          <p:nvPr/>
-        </p:nvPicPr>
-        <p:blipFill>
-          <a:blip r:embed="rId4" cstate="email">
-            <a:extLst>
-              <a:ext uri="{28A0092B-C50C-407E-A947-70E740481C1C}">
-                <a14:useLocalDpi xmlns:a14="http://schemas.microsoft.com/office/drawing/2010/main"/>
-              </a:ext>
-            </a:extLst>
-          </a:blip>
-          <a:stretch>
-            <a:fillRect/>
-          </a:stretch>
-        </p:blipFill>
-        <p:spPr>
-          <a:xfrm>
-            <a:off x="1163637" y="668326"/>
-            <a:ext cx="1495481" cy="307484"/>
-          </a:xfrm>
-          <a:prstGeom prst="rect">
-            <a:avLst/>
-          </a:prstGeom>
-          <a:ln w="12700">
-            <a:miter lim="400000"/>
-          </a:ln>
-        </p:spPr>
-      </p:pic>
-      <p:sp>
-        <p:nvSpPr>
-          <p:cNvPr id="379" name="Text Placeholder 3"/>
-          <p:cNvSpPr txBox="1"/>
-          <p:nvPr/>
-        </p:nvSpPr>
-        <p:spPr>
-          <a:xfrm>
-            <a:off x="1163637" y="5798021"/>
-            <a:ext cx="4968876" cy="215444"/>
-          </a:xfrm>
-          <a:prstGeom prst="rect">
-            <a:avLst/>
-          </a:prstGeom>
-          <a:ln w="12700">
-            <a:miter lim="400000"/>
-          </a:ln>
-          <a:extLst>
-            <a:ext uri="{C572A759-6A51-4108-AA02-DFA0A04FC94B}">
-              <ma14:wrappingTextBoxFlag xmlns="" xmlns:m="http://schemas.openxmlformats.org/officeDocument/2006/math" xmlns:a14="http://schemas.microsoft.com/office/drawing/2010/main" xmlns:ma14="http://schemas.microsoft.com/office/mac/drawingml/2011/main" val="1"/>
-            </a:ext>
-          </a:extLst>
-        </p:spPr>
-        <p:txBody>
-          <a:bodyPr wrap="square" lIns="0" tIns="0" rIns="0" bIns="0" anchor="b">
-            <a:spAutoFit/>
-          </a:bodyPr>
-          <a:lstStyle>
-            <a:lvl1pPr defTabSz="359999">
-              <a:defRPr sz="1400">
-                <a:solidFill>
-                  <a:srgbClr val="3F4851"/>
-                </a:solidFill>
-                <a:latin typeface="SB Sans Text Light"/>
-                <a:ea typeface="SB Sans Text Light"/>
-                <a:cs typeface="SB Sans Text Light"/>
-                <a:sym typeface="SB Sans Text Light"/>
-              </a:defRPr>
-            </a:lvl1pPr>
-          </a:lstStyle>
-          <a:p>
-            <a:r>
-              <a:rPr lang="ru-RU" dirty="0"/>
-              <a:t>Октябрь 2026</a:t>
-            </a:r>
-          </a:p>
-        </p:txBody>
-      </p:sp>
-      <p:sp>
-        <p:nvSpPr>
-          <p:cNvPr id="11" name="TextBox 10">
-            <a:extLst>
-              <a:ext uri="{FF2B5EF4-FFF2-40B4-BE49-F238E27FC236}">
-                <a16:creationId xmlns:a16="http://schemas.microsoft.com/office/drawing/2014/main" id="{6E781A54-7BEA-464D-BE1E-B3D62E989D7D}"/>
-              </a:ext>
-            </a:extLst>
-          </p:cNvPr>
-          <p:cNvSpPr txBox="1"/>
-          <p:nvPr/>
-        </p:nvSpPr>
-        <p:spPr>
-          <a:xfrm>
-            <a:off x="1163637" y="2751319"/>
-            <a:ext cx="5177421" cy="1338824"/>
-          </a:xfrm>
-          <a:prstGeom prst="rect">
-            <a:avLst/>
-          </a:prstGeom>
-          <a:noFill/>
-          <a:ln w="12700" cap="flat">
-            <a:noFill/>
-            <a:miter lim="400000"/>
-          </a:ln>
-          <a:effectLst/>
-          <a:sp3d/>
-        </p:spPr>
-        <p:style>
-          <a:lnRef idx="0">
-            <a:scrgbClr r="0" g="0" b="0"/>
-          </a:lnRef>
-          <a:fillRef idx="0">
-            <a:scrgbClr r="0" g="0" b="0"/>
-          </a:fillRef>
-          <a:effectRef idx="0">
-            <a:scrgbClr r="0" g="0" b="0"/>
-          </a:effectRef>
-          <a:fontRef idx="none"/>
-        </p:style>
-        <p:txBody>
-          <a:bodyPr rot="0" spcFirstLastPara="1" vertOverflow="overflow" horzOverflow="overflow" vert="horz" wrap="square" lIns="45718" tIns="45718" rIns="45718" bIns="45718" numCol="1" spcCol="38100" rtlCol="0" anchor="t">
-            <a:spAutoFit/>
-          </a:bodyPr>
-          <a:lstStyle/>
-          <a:p>
-            <a:pPr marL="0" marR="0" indent="0" algn="l" defTabSz="914400" rtl="0" fontAlgn="auto" latinLnBrk="0" hangingPunct="0">
-              <a:lnSpc>
-                <a:spcPct val="90000"/>
-              </a:lnSpc>
-              <a:spcBef>
-                <a:spcPts val="0"/>
-              </a:spcBef>
-              <a:spcAft>
-                <a:spcPts val="0"/>
-              </a:spcAft>
-              <a:buClrTx/>
-              <a:buSzTx/>
-              <a:buFontTx/>
-              <a:buNone/>
-              <a:tabLst/>
-            </a:pPr>
-            <a:r>
-              <a:rPr lang="ru-RU" sz="3000" dirty="0">
-                <a:latin typeface="SB Sans Display Semibold" panose="020B0503040504020204" pitchFamily="34" charset="0"/>
-                <a:cs typeface="SB Sans Display Semibold" panose="020B0503040504020204" pitchFamily="34" charset="0"/>
-              </a:rPr>
-              <a:t>Спасибо</a:t>
-            </a:r>
-          </a:p>
-          <a:p>
-            <a:pPr marL="0" marR="0" indent="0" algn="l" defTabSz="914400" rtl="0" fontAlgn="auto" latinLnBrk="0" hangingPunct="0">
-              <a:lnSpc>
-                <a:spcPct val="90000"/>
-              </a:lnSpc>
-              <a:spcBef>
-                <a:spcPts val="0"/>
-              </a:spcBef>
-              <a:spcAft>
-                <a:spcPts val="0"/>
-              </a:spcAft>
-              <a:buClrTx/>
-              <a:buSzTx/>
-              <a:buFontTx/>
-              <a:buNone/>
-              <a:tabLst/>
-            </a:pPr>
-            <a:r>
-              <a:rPr lang="ru-RU" sz="3000" dirty="0">
-                <a:latin typeface="SB Sans Display" panose="020B0503040504020204" pitchFamily="34" charset="0"/>
-                <a:cs typeface="SB Sans Display" panose="020B0503040504020204" pitchFamily="34" charset="0"/>
-              </a:rPr>
-              <a:t>Отчёт и преза —</a:t>
-            </a:r>
-          </a:p>
-          <a:p>
-            <a:pPr marL="0" marR="0" indent="0" algn="l" defTabSz="914400" rtl="0" fontAlgn="auto" latinLnBrk="0" hangingPunct="0">
-              <a:lnSpc>
-                <a:spcPct val="90000"/>
-              </a:lnSpc>
-              <a:spcBef>
-                <a:spcPts val="0"/>
-              </a:spcBef>
-              <a:spcAft>
-                <a:spcPts val="0"/>
-              </a:spcAft>
-              <a:buClrTx/>
-              <a:buSzTx/>
-              <a:buFontTx/>
-              <a:buNone/>
-              <a:tabLst/>
-            </a:pPr>
-            <a:r>
-              <a:rPr lang="ru-RU" sz="3000" dirty="0">
-                <a:latin typeface="SB Sans Display" panose="020B0503040504020204" pitchFamily="34" charset="0"/>
-                <a:cs typeface="SB Sans Display" panose="020B0503040504020204" pitchFamily="34" charset="0"/>
-              </a:rPr>
-              <a:t>в репозитории</a:t>
-            </a:r>
           </a:p>
         </p:txBody>
       </p:sp>

</xml_diff>

<commit_message>
docs: standardize brokerage wording across banks
</commit_message>
<xml_diff>
--- a/russian-banks-api-research.pptx
+++ b/russian-banks-api-research.pptx
@@ -15887,370 +15887,6 @@
     </p:otherStyle>
   </p:txStyles>
 </p:sldMaster>
-</file>
-
-<file path=ppt/slides/slide1.xml><?xml version="1.0" encoding="utf-8"?>
-<p:sld xmlns:a="http://schemas.openxmlformats.org/drawingml/2006/main" xmlns:r="http://schemas.openxmlformats.org/officeDocument/2006/relationships" xmlns:p="http://schemas.openxmlformats.org/presentationml/2006/main">
-  <p:cSld>
-    <p:spTree>
-      <p:nvGrpSpPr>
-        <p:cNvPr id="1" name=""/>
-        <p:cNvGrpSpPr/>
-        <p:nvPr/>
-      </p:nvGrpSpPr>
-      <p:grpSpPr>
-        <a:xfrm>
-          <a:off x="0" y="0"/>
-          <a:ext cx="0" cy="0"/>
-          <a:chOff x="0" y="0"/>
-          <a:chExt cx="0" cy="0"/>
-        </a:xfrm>
-      </p:grpSpPr>
-      <p:pic>
-        <p:nvPicPr>
-          <p:cNvPr id="3" name="Рисунок 2">
-            <a:extLst>
-              <a:ext uri="{FF2B5EF4-FFF2-40B4-BE49-F238E27FC236}">
-                <a16:creationId xmlns:a16="http://schemas.microsoft.com/office/drawing/2014/main" id="{B3FD0DC7-A0AA-8E46-A52B-B44F27D857EB}"/>
-              </a:ext>
-            </a:extLst>
-          </p:cNvPr>
-          <p:cNvPicPr>
-            <a:picLocks noChangeAspect="1"/>
-          </p:cNvPicPr>
-          <p:nvPr/>
-        </p:nvPicPr>
-        <p:blipFill rotWithShape="1">
-          <a:blip r:embed="rId3" cstate="email">
-            <a:alphaModFix/>
-            <a:extLst>
-              <a:ext uri="{28A0092B-C50C-407E-A947-70E740481C1C}">
-                <a14:useLocalDpi xmlns:a14="http://schemas.microsoft.com/office/drawing/2010/main"/>
-              </a:ext>
-            </a:extLst>
-          </a:blip>
-          <a:srcRect/>
-          <a:stretch/>
-        </p:blipFill>
-        <p:spPr>
-          <a:xfrm>
-            <a:off x="3218219" y="0"/>
-            <a:ext cx="8973782" cy="6879759"/>
-          </a:xfrm>
-          <a:prstGeom prst="rect">
-            <a:avLst/>
-          </a:prstGeom>
-        </p:spPr>
-      </p:pic>
-      <p:sp>
-        <p:nvSpPr>
-          <p:cNvPr id="8" name="Прямоугольник">
-            <a:extLst>
-              <a:ext uri="{FF2B5EF4-FFF2-40B4-BE49-F238E27FC236}">
-                <a16:creationId xmlns:a16="http://schemas.microsoft.com/office/drawing/2014/main" id="{38AF4049-ECF2-3C44-9AF4-FCFEAD35A479}"/>
-              </a:ext>
-            </a:extLst>
-          </p:cNvPr>
-          <p:cNvSpPr/>
-          <p:nvPr/>
-        </p:nvSpPr>
-        <p:spPr>
-          <a:xfrm>
-            <a:off x="-1086567" y="-3420818"/>
-            <a:ext cx="9469284" cy="15808703"/>
-          </a:xfrm>
-          <a:prstGeom prst="rect">
-            <a:avLst/>
-          </a:prstGeom>
-          <a:gradFill>
-            <a:gsLst>
-              <a:gs pos="50843">
-                <a:srgbClr val="FFFFFF"/>
-              </a:gs>
-              <a:gs pos="78055">
-                <a:srgbClr val="FFFFFF">
-                  <a:alpha val="50000"/>
-                </a:srgbClr>
-              </a:gs>
-              <a:gs pos="100000">
-                <a:srgbClr val="FFFFFF">
-                  <a:alpha val="0"/>
-                </a:srgbClr>
-              </a:gs>
-            </a:gsLst>
-            <a:path>
-              <a:fillToRect l="-4239" t="49577" r="104239" b="50422"/>
-            </a:path>
-          </a:gradFill>
-          <a:ln w="12700">
-            <a:miter lim="400000"/>
-          </a:ln>
-        </p:spPr>
-        <p:txBody>
-          <a:bodyPr lIns="45718" tIns="45718" rIns="45718" bIns="45718" anchor="ctr"/>
-          <a:lstStyle/>
-          <a:p>
-            <a:endParaRPr/>
-          </a:p>
-        </p:txBody>
-      </p:sp>
-      <p:sp>
-        <p:nvSpPr>
-          <p:cNvPr id="376" name="Text Placeholder 3"/>
-          <p:cNvSpPr txBox="1"/>
-          <p:nvPr/>
-        </p:nvSpPr>
-        <p:spPr>
-          <a:xfrm>
-            <a:off x="1708231" y="4782396"/>
-            <a:ext cx="2106506" cy="228601"/>
-          </a:xfrm>
-          <a:prstGeom prst="rect">
-            <a:avLst/>
-          </a:prstGeom>
-          <a:ln w="12700">
-            <a:miter lim="400000"/>
-          </a:ln>
-          <a:extLst>
-            <a:ext uri="{C572A759-6A51-4108-AA02-DFA0A04FC94B}">
-              <ma14:wrappingTextBoxFlag xmlns="" xmlns:m="http://schemas.openxmlformats.org/officeDocument/2006/math" xmlns:a14="http://schemas.microsoft.com/office/drawing/2010/main" xmlns:ma14="http://schemas.microsoft.com/office/mac/drawingml/2011/main" val="1"/>
-            </a:ext>
-          </a:extLst>
-        </p:spPr>
-        <p:txBody>
-          <a:bodyPr lIns="0" tIns="0" rIns="0" bIns="0">
-            <a:spAutoFit/>
-          </a:bodyPr>
-          <a:lstStyle>
-            <a:lvl1pPr defTabSz="359999">
-              <a:defRPr sz="1400">
-                <a:solidFill>
-                  <a:srgbClr val="FFFFFF"/>
-                </a:solidFill>
-                <a:latin typeface="SB Sans Text Light"/>
-                <a:ea typeface="SB Sans Text Light"/>
-                <a:cs typeface="SB Sans Text Light"/>
-                <a:sym typeface="SB Sans Text Light"/>
-              </a:defRPr>
-            </a:lvl1pPr>
-          </a:lstStyle>
-          <a:p>
-            <a:r>
-              <a:t>2/06/2021</a:t>
-            </a:r>
-          </a:p>
-        </p:txBody>
-      </p:sp>
-      <p:pic>
-        <p:nvPicPr>
-          <p:cNvPr id="378" name="Object 3" descr="Object 3"/>
-          <p:cNvPicPr>
-            <a:picLocks noChangeAspect="1"/>
-          </p:cNvPicPr>
-          <p:nvPr/>
-        </p:nvPicPr>
-        <p:blipFill>
-          <a:blip r:embed="rId4" cstate="email">
-            <a:extLst>
-              <a:ext uri="{28A0092B-C50C-407E-A947-70E740481C1C}">
-                <a14:useLocalDpi xmlns:a14="http://schemas.microsoft.com/office/drawing/2010/main"/>
-              </a:ext>
-            </a:extLst>
-          </a:blip>
-          <a:stretch>
-            <a:fillRect/>
-          </a:stretch>
-        </p:blipFill>
-        <p:spPr>
-          <a:xfrm>
-            <a:off x="1163637" y="668326"/>
-            <a:ext cx="1495481" cy="307484"/>
-          </a:xfrm>
-          <a:prstGeom prst="rect">
-            <a:avLst/>
-          </a:prstGeom>
-          <a:ln w="12700">
-            <a:miter lim="400000"/>
-          </a:ln>
-        </p:spPr>
-      </p:pic>
-      <p:sp>
-        <p:nvSpPr>
-          <p:cNvPr id="379" name="Text Placeholder 3"/>
-          <p:cNvSpPr txBox="1"/>
-          <p:nvPr/>
-        </p:nvSpPr>
-        <p:spPr>
-          <a:xfrm>
-            <a:off x="1163637" y="5798021"/>
-            <a:ext cx="4968876" cy="215444"/>
-          </a:xfrm>
-          <a:prstGeom prst="rect">
-            <a:avLst/>
-          </a:prstGeom>
-          <a:ln w="12700">
-            <a:miter lim="400000"/>
-          </a:ln>
-          <a:extLst>
-            <a:ext uri="{C572A759-6A51-4108-AA02-DFA0A04FC94B}">
-              <ma14:wrappingTextBoxFlag xmlns="" xmlns:m="http://schemas.openxmlformats.org/officeDocument/2006/math" xmlns:a14="http://schemas.microsoft.com/office/drawing/2010/main" xmlns:ma14="http://schemas.microsoft.com/office/mac/drawingml/2011/main" val="1"/>
-            </a:ext>
-          </a:extLst>
-        </p:spPr>
-        <p:txBody>
-          <a:bodyPr wrap="square" lIns="0" tIns="0" rIns="0" bIns="0" anchor="b">
-            <a:spAutoFit/>
-          </a:bodyPr>
-          <a:lstStyle>
-            <a:lvl1pPr defTabSz="359999">
-              <a:defRPr sz="1400">
-                <a:solidFill>
-                  <a:srgbClr val="3F4851"/>
-                </a:solidFill>
-                <a:latin typeface="SB Sans Text Light"/>
-                <a:ea typeface="SB Sans Text Light"/>
-                <a:cs typeface="SB Sans Text Light"/>
-                <a:sym typeface="SB Sans Text Light"/>
-              </a:defRPr>
-            </a:lvl1pPr>
-          </a:lstStyle>
-          <a:p>
-            <a:r>
-              <a:rPr lang="ru-RU" dirty="0"/>
-              <a:t>Февраль 2021</a:t>
-            </a:r>
-          </a:p>
-        </p:txBody>
-      </p:sp>
-      <p:sp>
-        <p:nvSpPr>
-          <p:cNvPr id="11" name="TextBox 10">
-            <a:extLst>
-              <a:ext uri="{FF2B5EF4-FFF2-40B4-BE49-F238E27FC236}">
-                <a16:creationId xmlns:a16="http://schemas.microsoft.com/office/drawing/2014/main" id="{6E781A54-7BEA-464D-BE1E-B3D62E989D7D}"/>
-              </a:ext>
-            </a:extLst>
-          </p:cNvPr>
-          <p:cNvSpPr txBox="1"/>
-          <p:nvPr/>
-        </p:nvSpPr>
-        <p:spPr>
-          <a:xfrm>
-            <a:off x="1163637" y="2751319"/>
-            <a:ext cx="5177421" cy="1338824"/>
-          </a:xfrm>
-          <a:prstGeom prst="rect">
-            <a:avLst/>
-          </a:prstGeom>
-          <a:noFill/>
-          <a:ln w="12700" cap="flat">
-            <a:noFill/>
-            <a:miter lim="400000"/>
-          </a:ln>
-          <a:effectLst/>
-          <a:sp3d/>
-        </p:spPr>
-        <p:style>
-          <a:lnRef idx="0">
-            <a:scrgbClr r="0" g="0" b="0"/>
-          </a:lnRef>
-          <a:fillRef idx="0">
-            <a:scrgbClr r="0" g="0" b="0"/>
-          </a:fillRef>
-          <a:effectRef idx="0">
-            <a:scrgbClr r="0" g="0" b="0"/>
-          </a:effectRef>
-          <a:fontRef idx="none"/>
-        </p:style>
-        <p:txBody>
-          <a:bodyPr rot="0" spcFirstLastPara="1" vertOverflow="overflow" horzOverflow="overflow" vert="horz" wrap="square" lIns="45718" tIns="45718" rIns="45718" bIns="45718" numCol="1" spcCol="38100" rtlCol="0" anchor="t">
-            <a:spAutoFit/>
-          </a:bodyPr>
-          <a:lstStyle/>
-          <a:p>
-            <a:pPr marL="0" marR="0" indent="0" algn="l" defTabSz="914400" rtl="0" fontAlgn="auto" latinLnBrk="0" hangingPunct="0">
-              <a:lnSpc>
-                <a:spcPct val="90000"/>
-              </a:lnSpc>
-              <a:spcBef>
-                <a:spcPts val="0"/>
-              </a:spcBef>
-              <a:spcAft>
-                <a:spcPts val="0"/>
-              </a:spcAft>
-              <a:buClrTx/>
-              <a:buSzTx/>
-              <a:buFontTx/>
-              <a:buNone/>
-              <a:tabLst/>
-            </a:pPr>
-            <a:r>
-              <a:rPr lang="ru-RU" sz="3000" dirty="0">
-                <a:latin typeface="SB Sans Display Semibold" panose="020B0503040504020204" pitchFamily="34" charset="0"/>
-                <a:cs typeface="SB Sans Display Semibold" panose="020B0503040504020204" pitchFamily="34" charset="0"/>
-              </a:rPr>
-              <a:t>Заголовок.</a:t>
-            </a:r>
-          </a:p>
-          <a:p>
-            <a:pPr marL="0" marR="0" indent="0" algn="l" defTabSz="914400" rtl="0" fontAlgn="auto" latinLnBrk="0" hangingPunct="0">
-              <a:lnSpc>
-                <a:spcPct val="90000"/>
-              </a:lnSpc>
-              <a:spcBef>
-                <a:spcPts val="0"/>
-              </a:spcBef>
-              <a:spcAft>
-                <a:spcPts val="0"/>
-              </a:spcAft>
-              <a:buClrTx/>
-              <a:buSzTx/>
-              <a:buFontTx/>
-              <a:buNone/>
-              <a:tabLst/>
-            </a:pPr>
-            <a:r>
-              <a:rPr lang="ru-RU" sz="3000" dirty="0">
-                <a:latin typeface="SB Sans Display" panose="020B0503040504020204" pitchFamily="34" charset="0"/>
-                <a:cs typeface="SB Sans Display" panose="020B0503040504020204" pitchFamily="34" charset="0"/>
-              </a:rPr>
-              <a:t>С выделением первого</a:t>
-            </a:r>
-          </a:p>
-          <a:p>
-            <a:pPr marL="0" marR="0" indent="0" algn="l" defTabSz="914400" rtl="0" fontAlgn="auto" latinLnBrk="0" hangingPunct="0">
-              <a:lnSpc>
-                <a:spcPct val="90000"/>
-              </a:lnSpc>
-              <a:spcBef>
-                <a:spcPts val="0"/>
-              </a:spcBef>
-              <a:spcAft>
-                <a:spcPts val="0"/>
-              </a:spcAft>
-              <a:buClrTx/>
-              <a:buSzTx/>
-              <a:buFontTx/>
-              <a:buNone/>
-              <a:tabLst/>
-            </a:pPr>
-            <a:r>
-              <a:rPr lang="ru-RU" sz="3000" dirty="0">
-                <a:latin typeface="SB Sans Display" panose="020B0503040504020204" pitchFamily="34" charset="0"/>
-                <a:cs typeface="SB Sans Display" panose="020B0503040504020204" pitchFamily="34" charset="0"/>
-              </a:rPr>
-              <a:t>слова на верхней строчке</a:t>
-            </a:r>
-          </a:p>
-        </p:txBody>
-      </p:sp>
-    </p:spTree>
-  </p:cSld>
-  <p:clrMapOvr>
-    <a:masterClrMapping/>
-  </p:clrMapOvr>
-  <p:transition spd="med"/>
-</p:sld>
 </file>
 
 <file path=ppt/slides/slide1.xml><?xml version="1.0" encoding="utf-8"?>
@@ -21344,7 +20980,7 @@
                 <a:latin typeface="SB Sans Text Light" panose="020B0303040504020204" pitchFamily="34" charset="0"/>
                 <a:cs typeface="SB Sans Text Light" panose="020B0303040504020204" pitchFamily="34" charset="0"/>
               </a:rPr>
-              <a:t>Облигации, заявки, market data (Invest / PRO API)</a:t>
+              <a:t>Котировки и портфель; покупка/продажа ценных бумаг (T-Invest / Alfa PRO)</a:t>
             </a:r>
             <a:br>
               <a:rPr lang="ru-RU" sz="1200" dirty="0">
@@ -27424,7 +27060,7 @@
           <a:p>
             <a:r>
               <a:rPr dirty="0" err="1"/>
-              <a:t>T-API Business + T-Invest: платежи, депозиты, bonds, sandbox. Самый полный публичный каталог.</a:t>
+              <a:t>T-API Business + T-Invest: платежи, депозиты, котировки и покупка/продажа ценных бумаг.</a:t>
             </a:r>
             <a:r>
               <a:rPr dirty="0"/>
@@ -27952,7 +27588,7 @@
           <a:p>
             <a:r>
               <a:rPr lang="ru-RU" dirty="0"/>
-              <a:t>Alfa API + sandbox, Альфа-Линк H2H, Альфа-Инвестиции PRO API (заявки, market data).</a:t>
+              <a:t>Alfa API + Альфа-Линк H2H + Альфа-Инвестиции PRO: платежи, котировки и покупка/продажа ценных бумаг.</a:t>
             </a:r>
           </a:p>
           <a:p>

</xml_diff>